<commit_message>
Add quantitative synthesis of cohort funnel and update missing data percentages in presentation script
</commit_message>
<xml_diff>
--- a/apresentacao_preprocessamento_tb.pptx
+++ b/apresentacao_preprocessamento_tb.pptx
@@ -1329,7 +1329,7 @@
           <a:p/>
           <a:p>
             <a:r>
-              <a:t>"Para a análise gráfica exigida no Requisito 5, selecionamos o preditor clinicamente mais expressivo do nosso modelo: a FAIXA_ETARIA, que obteve a segunda maior associação geral e a primeira entre fatores biológicos, com V de Cramér de 0,1339 e qui-quadrado de 8.594,40.</a:t>
+              <a:t>"Para a análise gráfica exigida no Requisito 5, selecionamos o preditor clinicamente mais expressivo do nosso modelo: a FAIXA_ETARIA, que obteve a maior associação univariada geral do estudo (Top 1 geral), com V de Cramér de 0,1339 e qui-quadrado de 8.594,40.</a:t>
             </a:r>
           </a:p>
           <a:p>
@@ -1360,7 +1360,7 @@
           </a:p>
           <a:p>
             <a:r>
-              <a:t>• Gradiente de risco: Jovens 1,28% $_x000D_ightarrow$ Adultos 4,07% $_x000D_ightarrow$ Idosos 12,11% (9,46x maior).</a:t>
+              <a:t>• Gradiente de risco: Jovens 1,28% -&gt; Adultos 4,07% -&gt; Idosos 12,11% (9,46x maior).</a:t>
             </a:r>
           </a:p>
           <a:p>
@@ -2345,7 +2345,7 @@
           </a:p>
           <a:p>
             <a:r>
-              <a:t>• 108 colunas originais $_x000D_ightarrow$ 84 descartadas $_x000D_ightarrow$ 24 mantidas + 2 derivadas = 26 preditoras.</a:t>
+              <a:t>• 108 colunas originais -&gt; 84 descartadas -&gt; 24 mantidas + 2 derivadas = 26 preditoras.</a:t>
             </a:r>
           </a:p>
           <a:p>
@@ -22764,7 +22764,7 @@
               </a:defRPr>
             </a:pPr>
             <a:r>
-              <a:t>• 1. Constantes (&gt;99% único valor): 12 colunas descartadas (ex.: TP_NOT, FORMA [100% pulmonar], ID_AGRAVO, ID_PAIS).</a:t>
+              <a:t>• 1. Constantes (&gt;99% único valor): Descartadas por ausência de variância (ex.: TP_NOT, FORMA [100% pulmonar], ID_AGRAVO, ID_PAIS, IDADEminutos).</a:t>
             </a:r>
           </a:p>
           <a:p>
@@ -22780,7 +22780,7 @@
               </a:defRPr>
             </a:pPr>
             <a:r>
-              <a:t>• 2. Faltantes (&gt;60% ausência estrutural): 46 colunas descartadas (esquemas de rifampicina, isoniazida e pirazinamida com ~64% nulos; teste molecular com 62%; cultura com 65%; CS_GESTANT com 74,67%).</a:t>
+              <a:t>• 2. Faltantes (&gt;60% ausência na base bruta): 38 colunas originais descartadas (esquemas de rifampicina, isoniazida, pirazinamida com 66,83% nulos; migração e transferências &gt;66% a 100%; ID_OCUPA_N com 80,10%; CAPITAL com 62,29%).</a:t>
             </a:r>
           </a:p>
           <a:p>
@@ -22796,7 +22796,7 @@
               </a:defRPr>
             </a:pPr>
             <a:r>
-              <a:t>• 3. Redundantes / Derivadas: 15 colunas descartadas (idades brutas, datas completas substituídas por ANO_DIAG, municípios).</a:t>
+              <a:t>• 3. Redundantes / Derivadas: Descartadas por duplicação (idades em dias/meses/anos substituídas por IDADE_ANOS; datas completas substituídas por ANO_DIAG; municípios agregados em SG_UF e REGIAO; NU_CONTATO).</a:t>
             </a:r>
           </a:p>
           <a:p>
@@ -22812,7 +22812,7 @@
               </a:defRPr>
             </a:pPr>
             <a:r>
-              <a:t>• 4. Vazamento Temporal: 11 colunas descartadas (DT_ENCERRA, baciloscopias de evolução mensal do 1º ao 6º mês, transferências).</a:t>
+              <a:t>• 4. Vazamento Temporal e Alvo: Descartadas por ocorrerem pós-início do tratamento ou encerramento (DT_ENCERRA, baciloscopias mensais BACILOSC_1 a BACILOSC_6, BAC_APOS_6, TRATSUP_AT, DT_MUDANCA, SITUA_ENCE).</a:t>
             </a:r>
           </a:p>
           <a:p>
@@ -22828,7 +22828,7 @@
               </a:defRPr>
             </a:pPr>
             <a:r>
-              <a:t>• Independência Amostral: As regras fixas operam na base integral df_ativ antes de qualquer particionamento.</a:t>
+              <a:t>• Independência Amostral: As regras fixas operam na base integral antes de qualquer particionamento.</a:t>
             </a:r>
           </a:p>
         </p:txBody>

</xml_diff>